<commit_message>
Add GWO optimization results and update notebooks
Added new GWO optimization run results, including costs trend plot and logs. Updated RL parameters, test script, and multiple Jupyter notebooks to reflect recent changes and results
</commit_message>
<xml_diff>
--- a/Journal/Journal.pptx
+++ b/Journal/Journal.pptx
@@ -12,6 +12,8 @@
     <p:sldId id="260" r:id="rId6"/>
     <p:sldId id="261" r:id="rId7"/>
     <p:sldId id="262" r:id="rId8"/>
+    <p:sldId id="263" r:id="rId9"/>
+    <p:sldId id="264" r:id="rId10"/>
   </p:sldIdLst>
   <p:sldSz cx="12192000" cy="6858000"/>
   <p:notesSz cx="6858000" cy="9144000"/>
@@ -265,7 +267,7 @@
           <a:p>
             <a:fld id="{34719BE0-092F-4F2A-B894-44C044C14DA7}" type="datetimeFigureOut">
               <a:rPr lang="it-IT" smtClean="0"/>
-              <a:t>01/10/2025</a:t>
+              <a:t>06/10/2025</a:t>
             </a:fld>
             <a:endParaRPr lang="it-IT"/>
           </a:p>
@@ -463,7 +465,7 @@
           <a:p>
             <a:fld id="{34719BE0-092F-4F2A-B894-44C044C14DA7}" type="datetimeFigureOut">
               <a:rPr lang="it-IT" smtClean="0"/>
-              <a:t>01/10/2025</a:t>
+              <a:t>06/10/2025</a:t>
             </a:fld>
             <a:endParaRPr lang="it-IT"/>
           </a:p>
@@ -671,7 +673,7 @@
           <a:p>
             <a:fld id="{34719BE0-092F-4F2A-B894-44C044C14DA7}" type="datetimeFigureOut">
               <a:rPr lang="it-IT" smtClean="0"/>
-              <a:t>01/10/2025</a:t>
+              <a:t>06/10/2025</a:t>
             </a:fld>
             <a:endParaRPr lang="it-IT"/>
           </a:p>
@@ -869,7 +871,7 @@
           <a:p>
             <a:fld id="{34719BE0-092F-4F2A-B894-44C044C14DA7}" type="datetimeFigureOut">
               <a:rPr lang="it-IT" smtClean="0"/>
-              <a:t>01/10/2025</a:t>
+              <a:t>06/10/2025</a:t>
             </a:fld>
             <a:endParaRPr lang="it-IT"/>
           </a:p>
@@ -1144,7 +1146,7 @@
           <a:p>
             <a:fld id="{34719BE0-092F-4F2A-B894-44C044C14DA7}" type="datetimeFigureOut">
               <a:rPr lang="it-IT" smtClean="0"/>
-              <a:t>01/10/2025</a:t>
+              <a:t>06/10/2025</a:t>
             </a:fld>
             <a:endParaRPr lang="it-IT"/>
           </a:p>
@@ -1409,7 +1411,7 @@
           <a:p>
             <a:fld id="{34719BE0-092F-4F2A-B894-44C044C14DA7}" type="datetimeFigureOut">
               <a:rPr lang="it-IT" smtClean="0"/>
-              <a:t>01/10/2025</a:t>
+              <a:t>06/10/2025</a:t>
             </a:fld>
             <a:endParaRPr lang="it-IT"/>
           </a:p>
@@ -1821,7 +1823,7 @@
           <a:p>
             <a:fld id="{34719BE0-092F-4F2A-B894-44C044C14DA7}" type="datetimeFigureOut">
               <a:rPr lang="it-IT" smtClean="0"/>
-              <a:t>01/10/2025</a:t>
+              <a:t>06/10/2025</a:t>
             </a:fld>
             <a:endParaRPr lang="it-IT"/>
           </a:p>
@@ -1962,7 +1964,7 @@
           <a:p>
             <a:fld id="{34719BE0-092F-4F2A-B894-44C044C14DA7}" type="datetimeFigureOut">
               <a:rPr lang="it-IT" smtClean="0"/>
-              <a:t>01/10/2025</a:t>
+              <a:t>06/10/2025</a:t>
             </a:fld>
             <a:endParaRPr lang="it-IT"/>
           </a:p>
@@ -2075,7 +2077,7 @@
           <a:p>
             <a:fld id="{34719BE0-092F-4F2A-B894-44C044C14DA7}" type="datetimeFigureOut">
               <a:rPr lang="it-IT" smtClean="0"/>
-              <a:t>01/10/2025</a:t>
+              <a:t>06/10/2025</a:t>
             </a:fld>
             <a:endParaRPr lang="it-IT"/>
           </a:p>
@@ -2386,7 +2388,7 @@
           <a:p>
             <a:fld id="{34719BE0-092F-4F2A-B894-44C044C14DA7}" type="datetimeFigureOut">
               <a:rPr lang="it-IT" smtClean="0"/>
-              <a:t>01/10/2025</a:t>
+              <a:t>06/10/2025</a:t>
             </a:fld>
             <a:endParaRPr lang="it-IT"/>
           </a:p>
@@ -2674,7 +2676,7 @@
           <a:p>
             <a:fld id="{34719BE0-092F-4F2A-B894-44C044C14DA7}" type="datetimeFigureOut">
               <a:rPr lang="it-IT" smtClean="0"/>
-              <a:t>01/10/2025</a:t>
+              <a:t>06/10/2025</a:t>
             </a:fld>
             <a:endParaRPr lang="it-IT"/>
           </a:p>
@@ -2915,7 +2917,7 @@
           <a:p>
             <a:fld id="{34719BE0-092F-4F2A-B894-44C044C14DA7}" type="datetimeFigureOut">
               <a:rPr lang="it-IT" smtClean="0"/>
-              <a:t>01/10/2025</a:t>
+              <a:t>06/10/2025</a:t>
             </a:fld>
             <a:endParaRPr lang="it-IT"/>
           </a:p>
@@ -5871,6 +5873,494 @@
 </p:sld>
 </file>
 
+<file path=ppt/slides/slide8.xml><?xml version="1.0" encoding="utf-8"?>
+<p:sld xmlns:a="http://schemas.openxmlformats.org/drawingml/2006/main" xmlns:r="http://schemas.openxmlformats.org/officeDocument/2006/relationships" xmlns:p="http://schemas.openxmlformats.org/presentationml/2006/main">
+  <p:cSld>
+    <p:spTree>
+      <p:nvGrpSpPr>
+        <p:cNvPr id="1" name=""/>
+        <p:cNvGrpSpPr/>
+        <p:nvPr/>
+      </p:nvGrpSpPr>
+      <p:grpSpPr>
+        <a:xfrm>
+          <a:off x="0" y="0"/>
+          <a:ext cx="0" cy="0"/>
+          <a:chOff x="0" y="0"/>
+          <a:chExt cx="0" cy="0"/>
+        </a:xfrm>
+      </p:grpSpPr>
+      <p:sp>
+        <p:nvSpPr>
+          <p:cNvPr id="2" name="Titolo 1">
+            <a:extLst>
+              <a:ext uri="{FF2B5EF4-FFF2-40B4-BE49-F238E27FC236}">
+                <a16:creationId xmlns:a16="http://schemas.microsoft.com/office/drawing/2014/main" id="{B4AA08B5-F048-99AE-4C39-A8F6116CAC78}"/>
+              </a:ext>
+            </a:extLst>
+          </p:cNvPr>
+          <p:cNvSpPr>
+            <a:spLocks noGrp="1"/>
+          </p:cNvSpPr>
+          <p:nvPr>
+            <p:ph type="title"/>
+          </p:nvPr>
+        </p:nvSpPr>
+        <p:spPr/>
+        <p:txBody>
+          <a:bodyPr/>
+          <a:lstStyle/>
+          <a:p>
+            <a:r>
+              <a:rPr lang="it-IT"/>
+              <a:t>02.10.2025</a:t>
+            </a:r>
+            <a:endParaRPr lang="it-IT" dirty="0"/>
+          </a:p>
+        </p:txBody>
+      </p:sp>
+      <p:sp>
+        <p:nvSpPr>
+          <p:cNvPr id="3" name="Segnaposto contenuto 2">
+            <a:extLst>
+              <a:ext uri="{FF2B5EF4-FFF2-40B4-BE49-F238E27FC236}">
+                <a16:creationId xmlns:a16="http://schemas.microsoft.com/office/drawing/2014/main" id="{A085208B-ECB6-FD95-8CBD-257A69B863D3}"/>
+              </a:ext>
+            </a:extLst>
+          </p:cNvPr>
+          <p:cNvSpPr>
+            <a:spLocks noGrp="1"/>
+          </p:cNvSpPr>
+          <p:nvPr>
+            <p:ph idx="1"/>
+          </p:nvPr>
+        </p:nvSpPr>
+        <p:spPr>
+          <a:xfrm>
+            <a:off x="838200" y="1825625"/>
+            <a:ext cx="10515600" cy="1441887"/>
+          </a:xfrm>
+        </p:spPr>
+        <p:txBody>
+          <a:bodyPr/>
+          <a:lstStyle/>
+          <a:p>
+            <a:r>
+              <a:rPr lang="it-IT"/>
+              <a:t>GWO has been also bugfixed and executed. RL is performing better! Now it’s time to make it performing even better</a:t>
+            </a:r>
+          </a:p>
+          <a:p>
+            <a:r>
+              <a:rPr lang="it-IT"/>
+              <a:t>GWO Results:</a:t>
+            </a:r>
+            <a:endParaRPr lang="it-IT" dirty="0"/>
+          </a:p>
+        </p:txBody>
+      </p:sp>
+      <p:pic>
+        <p:nvPicPr>
+          <p:cNvPr id="5" name="Immagine 4">
+            <a:extLst>
+              <a:ext uri="{FF2B5EF4-FFF2-40B4-BE49-F238E27FC236}">
+                <a16:creationId xmlns:a16="http://schemas.microsoft.com/office/drawing/2014/main" id="{A82705D7-5E2D-E321-23B4-296902DC4855}"/>
+              </a:ext>
+            </a:extLst>
+          </p:cNvPr>
+          <p:cNvPicPr>
+            <a:picLocks noChangeAspect="1"/>
+          </p:cNvPicPr>
+          <p:nvPr/>
+        </p:nvPicPr>
+        <p:blipFill>
+          <a:blip r:embed="rId2">
+            <a:extLst>
+              <a:ext uri="{28A0092B-C50C-407E-A947-70E740481C1C}">
+                <a14:useLocalDpi xmlns:a14="http://schemas.microsoft.com/office/drawing/2010/main" val="0"/>
+              </a:ext>
+            </a:extLst>
+          </a:blip>
+          <a:stretch>
+            <a:fillRect/>
+          </a:stretch>
+        </p:blipFill>
+        <p:spPr>
+          <a:xfrm>
+            <a:off x="838200" y="3544375"/>
+            <a:ext cx="5031539" cy="2746073"/>
+          </a:xfrm>
+          <a:prstGeom prst="rect">
+            <a:avLst/>
+          </a:prstGeom>
+        </p:spPr>
+      </p:pic>
+      <p:pic>
+        <p:nvPicPr>
+          <p:cNvPr id="7" name="Immagine 6">
+            <a:extLst>
+              <a:ext uri="{FF2B5EF4-FFF2-40B4-BE49-F238E27FC236}">
+                <a16:creationId xmlns:a16="http://schemas.microsoft.com/office/drawing/2014/main" id="{5FDC3141-454E-6EA4-EB8A-1B60BBCA5681}"/>
+              </a:ext>
+            </a:extLst>
+          </p:cNvPr>
+          <p:cNvPicPr>
+            <a:picLocks noChangeAspect="1"/>
+          </p:cNvPicPr>
+          <p:nvPr/>
+        </p:nvPicPr>
+        <p:blipFill>
+          <a:blip r:embed="rId3"/>
+          <a:stretch>
+            <a:fillRect/>
+          </a:stretch>
+        </p:blipFill>
+        <p:spPr>
+          <a:xfrm>
+            <a:off x="6288741" y="3429000"/>
+            <a:ext cx="3063534" cy="2868582"/>
+          </a:xfrm>
+          <a:prstGeom prst="rect">
+            <a:avLst/>
+          </a:prstGeom>
+        </p:spPr>
+      </p:pic>
+    </p:spTree>
+    <p:extLst>
+      <p:ext uri="{BB962C8B-B14F-4D97-AF65-F5344CB8AC3E}">
+        <p14:creationId xmlns:p14="http://schemas.microsoft.com/office/powerpoint/2010/main" val="2467424621"/>
+      </p:ext>
+    </p:extLst>
+  </p:cSld>
+  <p:clrMapOvr>
+    <a:masterClrMapping/>
+  </p:clrMapOvr>
+</p:sld>
+</file>
+
+<file path=ppt/slides/slide9.xml><?xml version="1.0" encoding="utf-8"?>
+<p:sld xmlns:a="http://schemas.openxmlformats.org/drawingml/2006/main" xmlns:r="http://schemas.openxmlformats.org/officeDocument/2006/relationships" xmlns:p="http://schemas.openxmlformats.org/presentationml/2006/main">
+  <p:cSld>
+    <p:spTree>
+      <p:nvGrpSpPr>
+        <p:cNvPr id="1" name=""/>
+        <p:cNvGrpSpPr/>
+        <p:nvPr/>
+      </p:nvGrpSpPr>
+      <p:grpSpPr>
+        <a:xfrm>
+          <a:off x="0" y="0"/>
+          <a:ext cx="0" cy="0"/>
+          <a:chOff x="0" y="0"/>
+          <a:chExt cx="0" cy="0"/>
+        </a:xfrm>
+      </p:grpSpPr>
+      <p:sp>
+        <p:nvSpPr>
+          <p:cNvPr id="2" name="Titolo 1">
+            <a:extLst>
+              <a:ext uri="{FF2B5EF4-FFF2-40B4-BE49-F238E27FC236}">
+                <a16:creationId xmlns:a16="http://schemas.microsoft.com/office/drawing/2014/main" id="{B3F0375E-A1F6-E754-F855-D62704A70696}"/>
+              </a:ext>
+            </a:extLst>
+          </p:cNvPr>
+          <p:cNvSpPr>
+            <a:spLocks noGrp="1"/>
+          </p:cNvSpPr>
+          <p:nvPr>
+            <p:ph type="title"/>
+          </p:nvPr>
+        </p:nvSpPr>
+        <p:spPr/>
+        <p:txBody>
+          <a:bodyPr/>
+          <a:lstStyle/>
+          <a:p>
+            <a:r>
+              <a:rPr lang="it-IT" dirty="0"/>
+              <a:t>06.10.2025</a:t>
+            </a:r>
+          </a:p>
+        </p:txBody>
+      </p:sp>
+      <p:sp>
+        <p:nvSpPr>
+          <p:cNvPr id="3" name="Segnaposto contenuto 2">
+            <a:extLst>
+              <a:ext uri="{FF2B5EF4-FFF2-40B4-BE49-F238E27FC236}">
+                <a16:creationId xmlns:a16="http://schemas.microsoft.com/office/drawing/2014/main" id="{DCF485A5-CEB2-2CA1-C80B-340E18CCE878}"/>
+              </a:ext>
+            </a:extLst>
+          </p:cNvPr>
+          <p:cNvSpPr>
+            <a:spLocks noGrp="1"/>
+          </p:cNvSpPr>
+          <p:nvPr>
+            <p:ph idx="1"/>
+          </p:nvPr>
+        </p:nvSpPr>
+        <p:spPr/>
+        <p:txBody>
+          <a:bodyPr/>
+          <a:lstStyle/>
+          <a:p>
+            <a:r>
+              <a:rPr lang="it-IT" dirty="0" err="1"/>
+              <a:t>Another</a:t>
+            </a:r>
+            <a:r>
+              <a:rPr lang="it-IT" dirty="0"/>
+              <a:t> </a:t>
+            </a:r>
+            <a:r>
+              <a:rPr lang="it-IT" dirty="0" err="1"/>
+              <a:t>doubt</a:t>
+            </a:r>
+            <a:r>
+              <a:rPr lang="it-IT" dirty="0"/>
+              <a:t>. </a:t>
+            </a:r>
+            <a:r>
+              <a:rPr lang="it-IT" dirty="0" err="1"/>
+              <a:t>Should</a:t>
+            </a:r>
+            <a:r>
+              <a:rPr lang="it-IT" dirty="0"/>
+              <a:t> I include </a:t>
+            </a:r>
+            <a:r>
+              <a:rPr lang="it-IT" dirty="0" err="1"/>
+              <a:t>distance</a:t>
+            </a:r>
+            <a:r>
+              <a:rPr lang="it-IT" dirty="0"/>
+              <a:t> from </a:t>
+            </a:r>
+            <a:r>
+              <a:rPr lang="it-IT" dirty="0" err="1"/>
+              <a:t>final</a:t>
+            </a:r>
+            <a:r>
+              <a:rPr lang="it-IT" dirty="0"/>
+              <a:t> target to the RL </a:t>
+            </a:r>
+            <a:r>
+              <a:rPr lang="it-IT" dirty="0" err="1"/>
+              <a:t>reward</a:t>
+            </a:r>
+            <a:r>
+              <a:rPr lang="it-IT" dirty="0"/>
+              <a:t>? </a:t>
+            </a:r>
+            <a:r>
+              <a:rPr lang="it-IT" dirty="0" err="1"/>
+              <a:t>It’s</a:t>
+            </a:r>
+            <a:r>
+              <a:rPr lang="it-IT" dirty="0"/>
+              <a:t> </a:t>
+            </a:r>
+            <a:r>
+              <a:rPr lang="it-IT" dirty="0" err="1"/>
+              <a:t>probably</a:t>
+            </a:r>
+            <a:r>
+              <a:rPr lang="it-IT" dirty="0"/>
+              <a:t> </a:t>
+            </a:r>
+            <a:r>
+              <a:rPr lang="it-IT" dirty="0" err="1"/>
+              <a:t>strictly</a:t>
+            </a:r>
+            <a:r>
+              <a:rPr lang="it-IT" dirty="0"/>
+              <a:t> </a:t>
+            </a:r>
+            <a:r>
+              <a:rPr lang="it-IT" dirty="0" err="1"/>
+              <a:t>not</a:t>
+            </a:r>
+            <a:r>
+              <a:rPr lang="it-IT" dirty="0"/>
+              <a:t> </a:t>
+            </a:r>
+            <a:r>
+              <a:rPr lang="it-IT" dirty="0" err="1"/>
+              <a:t>necessary</a:t>
+            </a:r>
+            <a:r>
+              <a:rPr lang="it-IT" dirty="0"/>
+              <a:t>, </a:t>
+            </a:r>
+            <a:r>
+              <a:rPr lang="it-IT" dirty="0" err="1"/>
+              <a:t>but</a:t>
+            </a:r>
+            <a:r>
+              <a:rPr lang="it-IT" dirty="0"/>
+              <a:t> </a:t>
+            </a:r>
+            <a:r>
+              <a:rPr lang="it-IT" dirty="0" err="1"/>
+              <a:t>should</a:t>
+            </a:r>
+            <a:r>
+              <a:rPr lang="it-IT" dirty="0"/>
+              <a:t> be </a:t>
+            </a:r>
+            <a:r>
+              <a:rPr lang="it-IT" dirty="0" err="1"/>
+              <a:t>worth</a:t>
+            </a:r>
+            <a:r>
+              <a:rPr lang="it-IT" dirty="0"/>
+              <a:t> </a:t>
+            </a:r>
+            <a:r>
+              <a:rPr lang="it-IT" dirty="0" err="1"/>
+              <a:t>it</a:t>
+            </a:r>
+            <a:r>
+              <a:rPr lang="it-IT" dirty="0"/>
+              <a:t> to check </a:t>
+            </a:r>
+            <a:r>
+              <a:rPr lang="it-IT" dirty="0" err="1"/>
+              <a:t>if</a:t>
+            </a:r>
+            <a:r>
+              <a:rPr lang="it-IT" dirty="0"/>
+              <a:t> </a:t>
+            </a:r>
+            <a:r>
+              <a:rPr lang="it-IT" dirty="0" err="1"/>
+              <a:t>it</a:t>
+            </a:r>
+            <a:r>
+              <a:rPr lang="it-IT" dirty="0"/>
+              <a:t> </a:t>
+            </a:r>
+            <a:r>
+              <a:rPr lang="it-IT" dirty="0" err="1"/>
+              <a:t>could</a:t>
+            </a:r>
+            <a:r>
+              <a:rPr lang="it-IT" dirty="0"/>
+              <a:t> </a:t>
+            </a:r>
+            <a:r>
+              <a:rPr lang="it-IT" dirty="0" err="1"/>
+              <a:t>improve</a:t>
+            </a:r>
+            <a:r>
+              <a:rPr lang="it-IT" dirty="0"/>
+              <a:t> </a:t>
+            </a:r>
+            <a:r>
+              <a:rPr lang="it-IT" dirty="0" err="1"/>
+              <a:t>convergence</a:t>
+            </a:r>
+            <a:r>
+              <a:rPr lang="it-IT" dirty="0"/>
+              <a:t>? </a:t>
+            </a:r>
+            <a:r>
+              <a:rPr lang="it-IT" dirty="0" err="1"/>
+              <a:t>Probably</a:t>
+            </a:r>
+            <a:r>
+              <a:rPr lang="it-IT" dirty="0"/>
+              <a:t> </a:t>
+            </a:r>
+            <a:r>
+              <a:rPr lang="it-IT" dirty="0" err="1"/>
+              <a:t>it</a:t>
+            </a:r>
+            <a:r>
+              <a:rPr lang="it-IT" dirty="0"/>
+              <a:t> </a:t>
+            </a:r>
+            <a:r>
+              <a:rPr lang="it-IT" dirty="0" err="1"/>
+              <a:t>would</a:t>
+            </a:r>
+            <a:r>
+              <a:rPr lang="it-IT" dirty="0"/>
+              <a:t> be good for </a:t>
+            </a:r>
+            <a:r>
+              <a:rPr lang="it-IT" dirty="0" err="1"/>
+              <a:t>generalization</a:t>
+            </a:r>
+            <a:r>
+              <a:rPr lang="it-IT" dirty="0"/>
+              <a:t> (</a:t>
+            </a:r>
+            <a:r>
+              <a:rPr lang="it-IT" dirty="0" err="1"/>
+              <a:t>that</a:t>
+            </a:r>
+            <a:r>
+              <a:rPr lang="it-IT" dirty="0"/>
+              <a:t> </a:t>
+            </a:r>
+            <a:r>
+              <a:rPr lang="it-IT" dirty="0" err="1"/>
+              <a:t>anyway</a:t>
+            </a:r>
+            <a:r>
+              <a:rPr lang="it-IT" dirty="0"/>
+              <a:t> </a:t>
+            </a:r>
+            <a:r>
+              <a:rPr lang="it-IT" dirty="0" err="1"/>
+              <a:t>cannot</a:t>
+            </a:r>
+            <a:r>
+              <a:rPr lang="it-IT" dirty="0"/>
+              <a:t> be </a:t>
+            </a:r>
+            <a:r>
+              <a:rPr lang="it-IT" dirty="0" err="1"/>
+              <a:t>accomplished</a:t>
+            </a:r>
+            <a:r>
+              <a:rPr lang="it-IT" dirty="0"/>
+              <a:t> in </a:t>
+            </a:r>
+            <a:r>
+              <a:rPr lang="it-IT" dirty="0" err="1"/>
+              <a:t>this</a:t>
+            </a:r>
+            <a:r>
+              <a:rPr lang="it-IT" dirty="0"/>
+              <a:t> </a:t>
+            </a:r>
+            <a:r>
+              <a:rPr lang="it-IT" dirty="0" err="1"/>
+              <a:t>context</a:t>
+            </a:r>
+            <a:r>
+              <a:rPr lang="it-IT"/>
+              <a:t>).</a:t>
+            </a:r>
+            <a:endParaRPr lang="it-IT" dirty="0"/>
+          </a:p>
+        </p:txBody>
+      </p:sp>
+    </p:spTree>
+    <p:extLst>
+      <p:ext uri="{BB962C8B-B14F-4D97-AF65-F5344CB8AC3E}">
+        <p14:creationId xmlns:p14="http://schemas.microsoft.com/office/powerpoint/2010/main" val="3866535004"/>
+      </p:ext>
+    </p:extLst>
+  </p:cSld>
+  <p:clrMapOvr>
+    <a:masterClrMapping/>
+  </p:clrMapOvr>
+</p:sld>
+</file>
+
 <file path=ppt/theme/theme1.xml><?xml version="1.0" encoding="utf-8"?>
 <a:theme xmlns:a="http://schemas.openxmlformats.org/drawingml/2006/main" name="Tema di Office">
   <a:themeElements>

</xml_diff>

<commit_message>
Added force-run specific episode
</commit_message>
<xml_diff>
--- a/Journal/Journal.pptx
+++ b/Journal/Journal.pptx
@@ -14,6 +14,7 @@
     <p:sldId id="262" r:id="rId8"/>
     <p:sldId id="263" r:id="rId9"/>
     <p:sldId id="264" r:id="rId10"/>
+    <p:sldId id="265" r:id="rId11"/>
   </p:sldIdLst>
   <p:sldSz cx="12192000" cy="6858000"/>
   <p:notesSz cx="6858000" cy="9144000"/>
@@ -267,7 +268,7 @@
           <a:p>
             <a:fld id="{34719BE0-092F-4F2A-B894-44C044C14DA7}" type="datetimeFigureOut">
               <a:rPr lang="it-IT" smtClean="0"/>
-              <a:t>06/10/2025</a:t>
+              <a:t>07/10/2025</a:t>
             </a:fld>
             <a:endParaRPr lang="it-IT"/>
           </a:p>
@@ -465,7 +466,7 @@
           <a:p>
             <a:fld id="{34719BE0-092F-4F2A-B894-44C044C14DA7}" type="datetimeFigureOut">
               <a:rPr lang="it-IT" smtClean="0"/>
-              <a:t>06/10/2025</a:t>
+              <a:t>07/10/2025</a:t>
             </a:fld>
             <a:endParaRPr lang="it-IT"/>
           </a:p>
@@ -673,7 +674,7 @@
           <a:p>
             <a:fld id="{34719BE0-092F-4F2A-B894-44C044C14DA7}" type="datetimeFigureOut">
               <a:rPr lang="it-IT" smtClean="0"/>
-              <a:t>06/10/2025</a:t>
+              <a:t>07/10/2025</a:t>
             </a:fld>
             <a:endParaRPr lang="it-IT"/>
           </a:p>
@@ -871,7 +872,7 @@
           <a:p>
             <a:fld id="{34719BE0-092F-4F2A-B894-44C044C14DA7}" type="datetimeFigureOut">
               <a:rPr lang="it-IT" smtClean="0"/>
-              <a:t>06/10/2025</a:t>
+              <a:t>07/10/2025</a:t>
             </a:fld>
             <a:endParaRPr lang="it-IT"/>
           </a:p>
@@ -1146,7 +1147,7 @@
           <a:p>
             <a:fld id="{34719BE0-092F-4F2A-B894-44C044C14DA7}" type="datetimeFigureOut">
               <a:rPr lang="it-IT" smtClean="0"/>
-              <a:t>06/10/2025</a:t>
+              <a:t>07/10/2025</a:t>
             </a:fld>
             <a:endParaRPr lang="it-IT"/>
           </a:p>
@@ -1411,7 +1412,7 @@
           <a:p>
             <a:fld id="{34719BE0-092F-4F2A-B894-44C044C14DA7}" type="datetimeFigureOut">
               <a:rPr lang="it-IT" smtClean="0"/>
-              <a:t>06/10/2025</a:t>
+              <a:t>07/10/2025</a:t>
             </a:fld>
             <a:endParaRPr lang="it-IT"/>
           </a:p>
@@ -1823,7 +1824,7 @@
           <a:p>
             <a:fld id="{34719BE0-092F-4F2A-B894-44C044C14DA7}" type="datetimeFigureOut">
               <a:rPr lang="it-IT" smtClean="0"/>
-              <a:t>06/10/2025</a:t>
+              <a:t>07/10/2025</a:t>
             </a:fld>
             <a:endParaRPr lang="it-IT"/>
           </a:p>
@@ -1964,7 +1965,7 @@
           <a:p>
             <a:fld id="{34719BE0-092F-4F2A-B894-44C044C14DA7}" type="datetimeFigureOut">
               <a:rPr lang="it-IT" smtClean="0"/>
-              <a:t>06/10/2025</a:t>
+              <a:t>07/10/2025</a:t>
             </a:fld>
             <a:endParaRPr lang="it-IT"/>
           </a:p>
@@ -2077,7 +2078,7 @@
           <a:p>
             <a:fld id="{34719BE0-092F-4F2A-B894-44C044C14DA7}" type="datetimeFigureOut">
               <a:rPr lang="it-IT" smtClean="0"/>
-              <a:t>06/10/2025</a:t>
+              <a:t>07/10/2025</a:t>
             </a:fld>
             <a:endParaRPr lang="it-IT"/>
           </a:p>
@@ -2388,7 +2389,7 @@
           <a:p>
             <a:fld id="{34719BE0-092F-4F2A-B894-44C044C14DA7}" type="datetimeFigureOut">
               <a:rPr lang="it-IT" smtClean="0"/>
-              <a:t>06/10/2025</a:t>
+              <a:t>07/10/2025</a:t>
             </a:fld>
             <a:endParaRPr lang="it-IT"/>
           </a:p>
@@ -2676,7 +2677,7 @@
           <a:p>
             <a:fld id="{34719BE0-092F-4F2A-B894-44C044C14DA7}" type="datetimeFigureOut">
               <a:rPr lang="it-IT" smtClean="0"/>
-              <a:t>06/10/2025</a:t>
+              <a:t>07/10/2025</a:t>
             </a:fld>
             <a:endParaRPr lang="it-IT"/>
           </a:p>
@@ -2917,7 +2918,7 @@
           <a:p>
             <a:fld id="{34719BE0-092F-4F2A-B894-44C044C14DA7}" type="datetimeFigureOut">
               <a:rPr lang="it-IT" smtClean="0"/>
-              <a:t>06/10/2025</a:t>
+              <a:t>07/10/2025</a:t>
             </a:fld>
             <a:endParaRPr lang="it-IT"/>
           </a:p>
@@ -3881,6 +3882,448 @@
 </p:sld>
 </file>
 
+<file path=ppt/slides/slide10.xml><?xml version="1.0" encoding="utf-8"?>
+<p:sld xmlns:a="http://schemas.openxmlformats.org/drawingml/2006/main" xmlns:r="http://schemas.openxmlformats.org/officeDocument/2006/relationships" xmlns:p="http://schemas.openxmlformats.org/presentationml/2006/main">
+  <p:cSld>
+    <p:spTree>
+      <p:nvGrpSpPr>
+        <p:cNvPr id="1" name=""/>
+        <p:cNvGrpSpPr/>
+        <p:nvPr/>
+      </p:nvGrpSpPr>
+      <p:grpSpPr>
+        <a:xfrm>
+          <a:off x="0" y="0"/>
+          <a:ext cx="0" cy="0"/>
+          <a:chOff x="0" y="0"/>
+          <a:chExt cx="0" cy="0"/>
+        </a:xfrm>
+      </p:grpSpPr>
+      <p:sp>
+        <p:nvSpPr>
+          <p:cNvPr id="2" name="Titolo 1">
+            <a:extLst>
+              <a:ext uri="{FF2B5EF4-FFF2-40B4-BE49-F238E27FC236}">
+                <a16:creationId xmlns:a16="http://schemas.microsoft.com/office/drawing/2014/main" id="{4D6A34C9-C5CC-7329-B5F8-42A9BBC4DD6E}"/>
+              </a:ext>
+            </a:extLst>
+          </p:cNvPr>
+          <p:cNvSpPr>
+            <a:spLocks noGrp="1"/>
+          </p:cNvSpPr>
+          <p:nvPr>
+            <p:ph type="title"/>
+          </p:nvPr>
+        </p:nvSpPr>
+        <p:spPr/>
+        <p:txBody>
+          <a:bodyPr/>
+          <a:lstStyle/>
+          <a:p>
+            <a:r>
+              <a:rPr lang="it-IT" dirty="0"/>
+              <a:t>07.10.2025</a:t>
+            </a:r>
+          </a:p>
+        </p:txBody>
+      </p:sp>
+      <p:sp>
+        <p:nvSpPr>
+          <p:cNvPr id="3" name="Segnaposto contenuto 2">
+            <a:extLst>
+              <a:ext uri="{FF2B5EF4-FFF2-40B4-BE49-F238E27FC236}">
+                <a16:creationId xmlns:a16="http://schemas.microsoft.com/office/drawing/2014/main" id="{B18B4973-78BB-271D-9BBB-8A38F1AEAC24}"/>
+              </a:ext>
+            </a:extLst>
+          </p:cNvPr>
+          <p:cNvSpPr>
+            <a:spLocks noGrp="1"/>
+          </p:cNvSpPr>
+          <p:nvPr>
+            <p:ph idx="1"/>
+          </p:nvPr>
+        </p:nvSpPr>
+        <p:spPr/>
+        <p:txBody>
+          <a:bodyPr/>
+          <a:lstStyle/>
+          <a:p>
+            <a:r>
+              <a:rPr lang="it-IT" dirty="0"/>
+              <a:t>Some </a:t>
+            </a:r>
+            <a:r>
+              <a:rPr lang="it-IT" dirty="0" err="1"/>
+              <a:t>considerations</a:t>
+            </a:r>
+            <a:r>
+              <a:rPr lang="it-IT" dirty="0"/>
+              <a:t> </a:t>
+            </a:r>
+            <a:r>
+              <a:rPr lang="it-IT" dirty="0" err="1"/>
+              <a:t>about</a:t>
+            </a:r>
+            <a:r>
+              <a:rPr lang="it-IT" dirty="0"/>
+              <a:t> </a:t>
+            </a:r>
+            <a:r>
+              <a:rPr lang="it-IT" dirty="0" err="1"/>
+              <a:t>hyperparameter</a:t>
+            </a:r>
+            <a:r>
+              <a:rPr lang="it-IT" dirty="0"/>
+              <a:t> tuning:</a:t>
+            </a:r>
+          </a:p>
+          <a:p>
+            <a:pPr lvl="1"/>
+            <a:r>
+              <a:rPr lang="it-IT" dirty="0" err="1"/>
+              <a:t>You</a:t>
+            </a:r>
+            <a:r>
+              <a:rPr lang="it-IT" dirty="0"/>
+              <a:t> </a:t>
+            </a:r>
+            <a:r>
+              <a:rPr lang="it-IT" dirty="0" err="1"/>
+              <a:t>cannot</a:t>
+            </a:r>
+            <a:r>
+              <a:rPr lang="it-IT" dirty="0"/>
+              <a:t> trust </a:t>
+            </a:r>
+            <a:r>
+              <a:rPr lang="it-IT" dirty="0" err="1"/>
+              <a:t>initial</a:t>
+            </a:r>
+            <a:r>
+              <a:rPr lang="it-IT" dirty="0"/>
+              <a:t> </a:t>
+            </a:r>
+            <a:r>
+              <a:rPr lang="it-IT" dirty="0" err="1"/>
+              <a:t>curves</a:t>
+            </a:r>
+            <a:r>
+              <a:rPr lang="it-IT" dirty="0"/>
+              <a:t> </a:t>
+            </a:r>
+            <a:r>
+              <a:rPr lang="it-IT" dirty="0" err="1"/>
+              <a:t>because</a:t>
+            </a:r>
+            <a:r>
+              <a:rPr lang="it-IT" dirty="0"/>
+              <a:t> </a:t>
+            </a:r>
+            <a:r>
+              <a:rPr lang="it-IT" dirty="0" err="1"/>
+              <a:t>it</a:t>
+            </a:r>
+            <a:r>
+              <a:rPr lang="it-IT" dirty="0"/>
+              <a:t> </a:t>
+            </a:r>
+            <a:r>
+              <a:rPr lang="it-IT" dirty="0" err="1"/>
+              <a:t>cannot</a:t>
+            </a:r>
+            <a:r>
+              <a:rPr lang="it-IT" dirty="0"/>
+              <a:t> </a:t>
+            </a:r>
+            <a:r>
+              <a:rPr lang="it-IT" dirty="0" err="1"/>
+              <a:t>say</a:t>
+            </a:r>
+            <a:r>
+              <a:rPr lang="it-IT" dirty="0"/>
+              <a:t> </a:t>
+            </a:r>
+            <a:r>
+              <a:rPr lang="it-IT" dirty="0" err="1"/>
+              <a:t>if</a:t>
+            </a:r>
+            <a:r>
+              <a:rPr lang="it-IT" dirty="0"/>
+              <a:t> the </a:t>
+            </a:r>
+            <a:r>
+              <a:rPr lang="it-IT" dirty="0" err="1"/>
+              <a:t>optimization</a:t>
+            </a:r>
+            <a:r>
+              <a:rPr lang="it-IT" dirty="0"/>
+              <a:t> </a:t>
+            </a:r>
+            <a:r>
+              <a:rPr lang="it-IT" dirty="0" err="1"/>
+              <a:t>will</a:t>
+            </a:r>
+            <a:r>
+              <a:rPr lang="it-IT" dirty="0"/>
+              <a:t> </a:t>
+            </a:r>
+            <a:r>
+              <a:rPr lang="it-IT" dirty="0" err="1"/>
+              <a:t>eventually</a:t>
+            </a:r>
+            <a:r>
+              <a:rPr lang="it-IT" dirty="0"/>
+              <a:t> drop </a:t>
+            </a:r>
+            <a:r>
+              <a:rPr lang="it-IT" dirty="0" err="1"/>
+              <a:t>later</a:t>
+            </a:r>
+            <a:r>
+              <a:rPr lang="it-IT" dirty="0"/>
+              <a:t>.</a:t>
+            </a:r>
+          </a:p>
+          <a:p>
+            <a:pPr lvl="1"/>
+            <a:r>
+              <a:rPr lang="it-IT" dirty="0" err="1"/>
+              <a:t>It’s</a:t>
+            </a:r>
+            <a:r>
+              <a:rPr lang="it-IT" dirty="0"/>
+              <a:t> </a:t>
+            </a:r>
+            <a:r>
+              <a:rPr lang="it-IT" dirty="0" err="1"/>
+              <a:t>important</a:t>
+            </a:r>
+            <a:r>
+              <a:rPr lang="it-IT" dirty="0"/>
+              <a:t> to </a:t>
+            </a:r>
+            <a:r>
+              <a:rPr lang="it-IT" dirty="0" err="1"/>
+              <a:t>measure</a:t>
+            </a:r>
+            <a:r>
+              <a:rPr lang="it-IT" dirty="0"/>
+              <a:t> standard </a:t>
+            </a:r>
+            <a:r>
+              <a:rPr lang="it-IT" dirty="0" err="1"/>
+              <a:t>deviation</a:t>
+            </a:r>
+            <a:r>
+              <a:rPr lang="it-IT" dirty="0"/>
+              <a:t> with </a:t>
+            </a:r>
+            <a:r>
+              <a:rPr lang="it-IT" dirty="0" err="1"/>
+              <a:t>seeds</a:t>
+            </a:r>
+            <a:r>
+              <a:rPr lang="it-IT" dirty="0"/>
+              <a:t> with a </a:t>
+            </a:r>
+            <a:r>
+              <a:rPr lang="it-IT" dirty="0" err="1"/>
+              <a:t>certain</a:t>
+            </a:r>
+            <a:r>
+              <a:rPr lang="it-IT" dirty="0"/>
+              <a:t> </a:t>
+            </a:r>
+            <a:r>
+              <a:rPr lang="it-IT" dirty="0" err="1"/>
+              <a:t>configuration</a:t>
+            </a:r>
+            <a:r>
+              <a:rPr lang="it-IT" dirty="0"/>
+              <a:t> </a:t>
+            </a:r>
+            <a:r>
+              <a:rPr lang="it-IT" dirty="0" err="1"/>
+              <a:t>is</a:t>
+            </a:r>
+            <a:r>
+              <a:rPr lang="it-IT" dirty="0"/>
+              <a:t> </a:t>
+            </a:r>
+            <a:r>
+              <a:rPr lang="it-IT" dirty="0" err="1"/>
+              <a:t>chosen</a:t>
+            </a:r>
+            <a:r>
+              <a:rPr lang="it-IT" dirty="0"/>
+              <a:t> (some </a:t>
+            </a:r>
+            <a:r>
+              <a:rPr lang="it-IT" dirty="0" err="1"/>
+              <a:t>configurations</a:t>
+            </a:r>
+            <a:r>
+              <a:rPr lang="it-IT" dirty="0"/>
+              <a:t> can generate </a:t>
+            </a:r>
+            <a:r>
+              <a:rPr lang="it-IT" dirty="0" err="1"/>
+              <a:t>instable</a:t>
+            </a:r>
+            <a:r>
+              <a:rPr lang="it-IT" dirty="0"/>
+              <a:t> models or </a:t>
+            </a:r>
+            <a:r>
+              <a:rPr lang="it-IT" dirty="0" err="1"/>
+              <a:t>overfitted</a:t>
+            </a:r>
+            <a:r>
+              <a:rPr lang="it-IT" dirty="0"/>
+              <a:t> on a </a:t>
+            </a:r>
+            <a:r>
+              <a:rPr lang="it-IT" dirty="0" err="1"/>
+              <a:t>seed</a:t>
+            </a:r>
+            <a:r>
+              <a:rPr lang="it-IT" dirty="0"/>
+              <a:t>)</a:t>
+            </a:r>
+          </a:p>
+          <a:p>
+            <a:pPr lvl="1"/>
+            <a:r>
+              <a:rPr lang="it-IT" dirty="0"/>
+              <a:t>Focus on </a:t>
+            </a:r>
+            <a:r>
+              <a:rPr lang="it-IT" dirty="0" err="1"/>
+              <a:t>hyperparameters</a:t>
+            </a:r>
+            <a:r>
+              <a:rPr lang="it-IT" dirty="0"/>
+              <a:t> </a:t>
+            </a:r>
+            <a:r>
+              <a:rPr lang="it-IT" dirty="0" err="1"/>
+              <a:t>that</a:t>
+            </a:r>
+            <a:r>
+              <a:rPr lang="it-IT" dirty="0"/>
+              <a:t> </a:t>
+            </a:r>
+            <a:r>
+              <a:rPr lang="it-IT" dirty="0" err="1"/>
+              <a:t>have</a:t>
+            </a:r>
+            <a:r>
+              <a:rPr lang="it-IT" dirty="0"/>
+              <a:t> the </a:t>
+            </a:r>
+            <a:r>
+              <a:rPr lang="it-IT" dirty="0" err="1"/>
+              <a:t>strongest</a:t>
+            </a:r>
+            <a:r>
+              <a:rPr lang="it-IT" dirty="0"/>
+              <a:t> impact</a:t>
+            </a:r>
+          </a:p>
+          <a:p>
+            <a:pPr lvl="1"/>
+            <a:r>
+              <a:rPr lang="it-IT" dirty="0"/>
+              <a:t>Use Area Under the Curve (AUC) </a:t>
+            </a:r>
+            <a:r>
+              <a:rPr lang="it-IT" dirty="0" err="1"/>
+              <a:t>that</a:t>
+            </a:r>
+            <a:r>
+              <a:rPr lang="it-IT" dirty="0"/>
+              <a:t> </a:t>
+            </a:r>
+            <a:r>
+              <a:rPr lang="it-IT" dirty="0" err="1"/>
+              <a:t>captures</a:t>
+            </a:r>
+            <a:r>
+              <a:rPr lang="it-IT" dirty="0"/>
+              <a:t> </a:t>
+            </a:r>
+            <a:r>
+              <a:rPr lang="it-IT" dirty="0" err="1"/>
+              <a:t>both</a:t>
+            </a:r>
+            <a:r>
+              <a:rPr lang="it-IT" dirty="0"/>
+              <a:t> learning speed and best cost. </a:t>
+            </a:r>
+            <a:r>
+              <a:rPr lang="it-IT" dirty="0" err="1"/>
+              <a:t>It</a:t>
+            </a:r>
+            <a:r>
+              <a:rPr lang="it-IT" dirty="0"/>
+              <a:t> can be </a:t>
+            </a:r>
+            <a:r>
+              <a:rPr lang="it-IT" dirty="0" err="1"/>
+              <a:t>normalized</a:t>
+            </a:r>
+            <a:r>
+              <a:rPr lang="it-IT" dirty="0"/>
+              <a:t> by the duration to </a:t>
+            </a:r>
+            <a:r>
+              <a:rPr lang="it-IT" dirty="0" err="1"/>
+              <a:t>get</a:t>
+            </a:r>
+            <a:r>
+              <a:rPr lang="it-IT" dirty="0"/>
+              <a:t> the </a:t>
+            </a:r>
+            <a:r>
+              <a:rPr lang="it-IT" dirty="0" err="1"/>
+              <a:t>average</a:t>
+            </a:r>
+            <a:r>
+              <a:rPr lang="it-IT" dirty="0"/>
+              <a:t> over time.</a:t>
+            </a:r>
+          </a:p>
+          <a:p>
+            <a:r>
+              <a:rPr lang="it-IT" dirty="0"/>
+              <a:t>Source: </a:t>
+            </a:r>
+            <a:r>
+              <a:rPr lang="it-IT" dirty="0">
+                <a:hlinkClick r:id="rId2"/>
+              </a:rPr>
+              <a:t>https://proceedings.mlr.press/v202/eimer23a</a:t>
+            </a:r>
+            <a:r>
+              <a:rPr lang="it-IT" dirty="0"/>
+              <a:t> </a:t>
+            </a:r>
+          </a:p>
+        </p:txBody>
+      </p:sp>
+    </p:spTree>
+    <p:extLst>
+      <p:ext uri="{BB962C8B-B14F-4D97-AF65-F5344CB8AC3E}">
+        <p14:creationId xmlns:p14="http://schemas.microsoft.com/office/powerpoint/2010/main" val="3123277170"/>
+      </p:ext>
+    </p:extLst>
+  </p:cSld>
+  <p:clrMapOvr>
+    <a:masterClrMapping/>
+  </p:clrMapOvr>
+</p:sld>
+</file>
+
 <file path=ppt/slides/slide2.xml><?xml version="1.0" encoding="utf-8"?>
 <p:sld xmlns:a="http://schemas.openxmlformats.org/drawingml/2006/main" xmlns:r="http://schemas.openxmlformats.org/officeDocument/2006/relationships" xmlns:p="http://schemas.openxmlformats.org/presentationml/2006/main">
   <p:cSld>

</xml_diff>